<commit_message>
UPDATE - MP Fix presentacion Metodologia Tesis - 20260318
</commit_message>
<xml_diff>
--- a/Semestre_3/Metodologia de Proyectos/Presentacion_Tesis.pptx
+++ b/Semestre_3/Metodologia de Proyectos/Presentacion_Tesis.pptx
@@ -233,7 +233,7 @@
           <a:p>
             <a:fld id="{93A08C56-340B-4323-9489-5BB3250B74C8}" type="datetimeFigureOut">
               <a:rPr lang="es-MX" smtClean="0"/>
-              <a:t>02/03/2026</a:t>
+              <a:t>11/03/2026</a:t>
             </a:fld>
             <a:endParaRPr lang="es-MX"/>
           </a:p>
@@ -777,7 +777,7 @@
             <a:fld id="{1D8BD707-D9CF-40AE-B4C6-C98DA3205C09}" type="datetimeFigureOut">
               <a:rPr lang="en-US" smtClean="0"/>
               <a:pPr/>
-              <a:t>3/2/2026</a:t>
+              <a:t>3/11/2026</a:t>
             </a:fld>
             <a:endParaRPr lang="en-US"/>
           </a:p>
@@ -942,7 +942,7 @@
             <a:fld id="{1D8BD707-D9CF-40AE-B4C6-C98DA3205C09}" type="datetimeFigureOut">
               <a:rPr lang="en-US" smtClean="0"/>
               <a:pPr/>
-              <a:t>3/2/2026</a:t>
+              <a:t>3/11/2026</a:t>
             </a:fld>
             <a:endParaRPr lang="en-US"/>
           </a:p>
@@ -1117,7 +1117,7 @@
             <a:fld id="{1D8BD707-D9CF-40AE-B4C6-C98DA3205C09}" type="datetimeFigureOut">
               <a:rPr lang="en-US" smtClean="0"/>
               <a:pPr/>
-              <a:t>3/2/2026</a:t>
+              <a:t>3/11/2026</a:t>
             </a:fld>
             <a:endParaRPr lang="en-US"/>
           </a:p>
@@ -1282,7 +1282,7 @@
             <a:fld id="{1D8BD707-D9CF-40AE-B4C6-C98DA3205C09}" type="datetimeFigureOut">
               <a:rPr lang="en-US" smtClean="0"/>
               <a:pPr/>
-              <a:t>3/2/2026</a:t>
+              <a:t>3/11/2026</a:t>
             </a:fld>
             <a:endParaRPr lang="en-US"/>
           </a:p>
@@ -1524,7 +1524,7 @@
             <a:fld id="{1D8BD707-D9CF-40AE-B4C6-C98DA3205C09}" type="datetimeFigureOut">
               <a:rPr lang="en-US" smtClean="0"/>
               <a:pPr/>
-              <a:t>3/2/2026</a:t>
+              <a:t>3/11/2026</a:t>
             </a:fld>
             <a:endParaRPr lang="en-US"/>
           </a:p>
@@ -1806,7 +1806,7 @@
             <a:fld id="{1D8BD707-D9CF-40AE-B4C6-C98DA3205C09}" type="datetimeFigureOut">
               <a:rPr lang="en-US" smtClean="0"/>
               <a:pPr/>
-              <a:t>3/2/2026</a:t>
+              <a:t>3/11/2026</a:t>
             </a:fld>
             <a:endParaRPr lang="en-US"/>
           </a:p>
@@ -2222,7 +2222,7 @@
             <a:fld id="{1D8BD707-D9CF-40AE-B4C6-C98DA3205C09}" type="datetimeFigureOut">
               <a:rPr lang="en-US" smtClean="0"/>
               <a:pPr/>
-              <a:t>3/2/2026</a:t>
+              <a:t>3/11/2026</a:t>
             </a:fld>
             <a:endParaRPr lang="en-US"/>
           </a:p>
@@ -2336,7 +2336,7 @@
             <a:fld id="{1D8BD707-D9CF-40AE-B4C6-C98DA3205C09}" type="datetimeFigureOut">
               <a:rPr lang="en-US" smtClean="0"/>
               <a:pPr/>
-              <a:t>3/2/2026</a:t>
+              <a:t>3/11/2026</a:t>
             </a:fld>
             <a:endParaRPr lang="en-US"/>
           </a:p>
@@ -2428,7 +2428,7 @@
             <a:fld id="{1D8BD707-D9CF-40AE-B4C6-C98DA3205C09}" type="datetimeFigureOut">
               <a:rPr lang="en-US" smtClean="0"/>
               <a:pPr/>
-              <a:t>3/2/2026</a:t>
+              <a:t>3/11/2026</a:t>
             </a:fld>
             <a:endParaRPr lang="en-US"/>
           </a:p>
@@ -2700,7 +2700,7 @@
             <a:fld id="{1D8BD707-D9CF-40AE-B4C6-C98DA3205C09}" type="datetimeFigureOut">
               <a:rPr lang="en-US" smtClean="0"/>
               <a:pPr/>
-              <a:t>3/2/2026</a:t>
+              <a:t>3/11/2026</a:t>
             </a:fld>
             <a:endParaRPr lang="en-US"/>
           </a:p>
@@ -2949,7 +2949,7 @@
             <a:fld id="{1D8BD707-D9CF-40AE-B4C6-C98DA3205C09}" type="datetimeFigureOut">
               <a:rPr lang="en-US" smtClean="0"/>
               <a:pPr/>
-              <a:t>3/2/2026</a:t>
+              <a:t>3/11/2026</a:t>
             </a:fld>
             <a:endParaRPr lang="en-US"/>
           </a:p>
@@ -3157,7 +3157,7 @@
             <a:fld id="{1D8BD707-D9CF-40AE-B4C6-C98DA3205C09}" type="datetimeFigureOut">
               <a:rPr lang="en-US" smtClean="0"/>
               <a:pPr/>
-              <a:t>3/2/2026</a:t>
+              <a:t>3/11/2026</a:t>
             </a:fld>
             <a:endParaRPr lang="en-US"/>
           </a:p>
@@ -3858,7 +3858,7 @@
                 </a:solidFill>
                 <a:latin typeface="League Gothic"/>
               </a:rPr>
-              <a:t>Enero</a:t>
+              <a:t>Febrero</a:t>
             </a:r>
             <a:r>
               <a:rPr lang="en-US" sz="3299" spc="164" dirty="0">

</xml_diff>